<commit_message>
feat: Update configuration and add .gitignore for project setup
Co-authored-by: Copilot <copilot@github.com>
</commit_message>
<xml_diff>
--- a/Pomfret - dab - grillen - draft.pptx
+++ b/Pomfret - dab - grillen - draft.pptx
@@ -5,7 +5,7 @@
     <p:sldMasterId id="2147483659" r:id="rId1"/>
   </p:sldMasterIdLst>
   <p:notesMasterIdLst>
-    <p:notesMasterId r:id="rId30"/>
+    <p:notesMasterId r:id="rId32"/>
   </p:notesMasterIdLst>
   <p:sldIdLst>
     <p:sldId id="268" r:id="rId2"/>
@@ -19,23 +19,25 @@
     <p:sldId id="293" r:id="rId10"/>
     <p:sldId id="297" r:id="rId11"/>
     <p:sldId id="273" r:id="rId12"/>
-    <p:sldId id="274" r:id="rId13"/>
-    <p:sldId id="275" r:id="rId14"/>
-    <p:sldId id="276" r:id="rId15"/>
-    <p:sldId id="277" r:id="rId16"/>
-    <p:sldId id="279" r:id="rId17"/>
-    <p:sldId id="280" r:id="rId18"/>
-    <p:sldId id="284" r:id="rId19"/>
-    <p:sldId id="281" r:id="rId20"/>
-    <p:sldId id="282" r:id="rId21"/>
-    <p:sldId id="283" r:id="rId22"/>
-    <p:sldId id="312" r:id="rId23"/>
-    <p:sldId id="285" r:id="rId24"/>
-    <p:sldId id="310" r:id="rId25"/>
-    <p:sldId id="286" r:id="rId26"/>
-    <p:sldId id="287" r:id="rId27"/>
-    <p:sldId id="288" r:id="rId28"/>
-    <p:sldId id="289" r:id="rId29"/>
+    <p:sldId id="313" r:id="rId13"/>
+    <p:sldId id="314" r:id="rId14"/>
+    <p:sldId id="274" r:id="rId15"/>
+    <p:sldId id="275" r:id="rId16"/>
+    <p:sldId id="276" r:id="rId17"/>
+    <p:sldId id="277" r:id="rId18"/>
+    <p:sldId id="279" r:id="rId19"/>
+    <p:sldId id="280" r:id="rId20"/>
+    <p:sldId id="284" r:id="rId21"/>
+    <p:sldId id="281" r:id="rId22"/>
+    <p:sldId id="282" r:id="rId23"/>
+    <p:sldId id="283" r:id="rId24"/>
+    <p:sldId id="312" r:id="rId25"/>
+    <p:sldId id="285" r:id="rId26"/>
+    <p:sldId id="310" r:id="rId27"/>
+    <p:sldId id="286" r:id="rId28"/>
+    <p:sldId id="287" r:id="rId29"/>
+    <p:sldId id="288" r:id="rId30"/>
+    <p:sldId id="289" r:id="rId31"/>
   </p:sldIdLst>
   <p:sldSz cx="9144000" cy="5143500" type="screen16x9"/>
   <p:notesSz cx="6858000" cy="9144000"/>
@@ -8857,6 +8859,236 @@
 </file>
 
 <file path=ppt/slides/slide12.xml><?xml version="1.0" encoding="utf-8"?>
+<p:sld xmlns:a="http://schemas.openxmlformats.org/drawingml/2006/main" xmlns:r="http://schemas.openxmlformats.org/officeDocument/2006/relationships" xmlns:p="http://schemas.openxmlformats.org/presentationml/2006/main" show="0">
+  <p:cSld>
+    <p:spTree>
+      <p:nvGrpSpPr>
+        <p:cNvPr id="1" name=""/>
+        <p:cNvGrpSpPr/>
+        <p:nvPr/>
+      </p:nvGrpSpPr>
+      <p:grpSpPr>
+        <a:xfrm>
+          <a:off x="0" y="0"/>
+          <a:ext cx="0" cy="0"/>
+          <a:chOff x="0" y="0"/>
+          <a:chExt cx="0" cy="0"/>
+        </a:xfrm>
+      </p:grpSpPr>
+      <p:sp>
+        <p:nvSpPr>
+          <p:cNvPr id="2" name="Title 1">
+            <a:extLst>
+              <a:ext uri="{FF2B5EF4-FFF2-40B4-BE49-F238E27FC236}">
+                <a16:creationId xmlns:a16="http://schemas.microsoft.com/office/drawing/2014/main" id="{5990771E-59F4-ECB4-C0C7-B458074E1A2F}"/>
+              </a:ext>
+            </a:extLst>
+          </p:cNvPr>
+          <p:cNvSpPr>
+            <a:spLocks noGrp="1"/>
+          </p:cNvSpPr>
+          <p:nvPr>
+            <p:ph type="title"/>
+          </p:nvPr>
+        </p:nvSpPr>
+        <p:spPr/>
+        <p:txBody>
+          <a:bodyPr>
+            <a:normAutofit fontScale="90000"/>
+          </a:bodyPr>
+          <a:lstStyle/>
+          <a:p>
+            <a:endParaRPr lang="en-GB"/>
+          </a:p>
+        </p:txBody>
+      </p:sp>
+      <p:sp>
+        <p:nvSpPr>
+          <p:cNvPr id="3" name="Text Placeholder 2">
+            <a:extLst>
+              <a:ext uri="{FF2B5EF4-FFF2-40B4-BE49-F238E27FC236}">
+                <a16:creationId xmlns:a16="http://schemas.microsoft.com/office/drawing/2014/main" id="{862CC05A-23E5-178A-7198-5FEEAC3DFBF8}"/>
+              </a:ext>
+            </a:extLst>
+          </p:cNvPr>
+          <p:cNvSpPr>
+            <a:spLocks noGrp="1"/>
+          </p:cNvSpPr>
+          <p:nvPr>
+            <p:ph type="body" idx="1"/>
+          </p:nvPr>
+        </p:nvSpPr>
+        <p:spPr/>
+        <p:txBody>
+          <a:bodyPr/>
+          <a:lstStyle/>
+          <a:p>
+            <a:endParaRPr lang="en-GB"/>
+          </a:p>
+        </p:txBody>
+      </p:sp>
+      <p:pic>
+        <p:nvPicPr>
+          <p:cNvPr id="5" name="Picture 4">
+            <a:extLst>
+              <a:ext uri="{FF2B5EF4-FFF2-40B4-BE49-F238E27FC236}">
+                <a16:creationId xmlns:a16="http://schemas.microsoft.com/office/drawing/2014/main" id="{2373A658-0095-1ACE-94F3-CAAC355C9C96}"/>
+              </a:ext>
+            </a:extLst>
+          </p:cNvPr>
+          <p:cNvPicPr>
+            <a:picLocks noChangeAspect="1"/>
+          </p:cNvPicPr>
+          <p:nvPr/>
+        </p:nvPicPr>
+        <p:blipFill>
+          <a:blip r:embed="rId2"/>
+          <a:stretch>
+            <a:fillRect/>
+          </a:stretch>
+        </p:blipFill>
+        <p:spPr>
+          <a:xfrm>
+            <a:off x="0" y="289497"/>
+            <a:ext cx="9144000" cy="4564505"/>
+          </a:xfrm>
+          <a:prstGeom prst="rect">
+            <a:avLst/>
+          </a:prstGeom>
+        </p:spPr>
+      </p:pic>
+    </p:spTree>
+    <p:extLst>
+      <p:ext uri="{BB962C8B-B14F-4D97-AF65-F5344CB8AC3E}">
+        <p14:creationId xmlns:p14="http://schemas.microsoft.com/office/powerpoint/2010/main" val="951035778"/>
+      </p:ext>
+    </p:extLst>
+  </p:cSld>
+  <p:clrMapOvr>
+    <a:masterClrMapping/>
+  </p:clrMapOvr>
+</p:sld>
+</file>
+
+<file path=ppt/slides/slide13.xml><?xml version="1.0" encoding="utf-8"?>
+<p:sld xmlns:a="http://schemas.openxmlformats.org/drawingml/2006/main" xmlns:r="http://schemas.openxmlformats.org/officeDocument/2006/relationships" xmlns:p="http://schemas.openxmlformats.org/presentationml/2006/main">
+  <p:cSld>
+    <p:spTree>
+      <p:nvGrpSpPr>
+        <p:cNvPr id="1" name="">
+          <a:extLst>
+            <a:ext uri="{FF2B5EF4-FFF2-40B4-BE49-F238E27FC236}">
+              <a16:creationId xmlns:a16="http://schemas.microsoft.com/office/drawing/2014/main" id="{E193D542-4AEE-4570-C037-0F577EE8D8DF}"/>
+            </a:ext>
+          </a:extLst>
+        </p:cNvPr>
+        <p:cNvGrpSpPr/>
+        <p:nvPr/>
+      </p:nvGrpSpPr>
+      <p:grpSpPr>
+        <a:xfrm>
+          <a:off x="0" y="0"/>
+          <a:ext cx="0" cy="0"/>
+          <a:chOff x="0" y="0"/>
+          <a:chExt cx="0" cy="0"/>
+        </a:xfrm>
+      </p:grpSpPr>
+      <p:sp>
+        <p:nvSpPr>
+          <p:cNvPr id="2" name="Title 1">
+            <a:extLst>
+              <a:ext uri="{FF2B5EF4-FFF2-40B4-BE49-F238E27FC236}">
+                <a16:creationId xmlns:a16="http://schemas.microsoft.com/office/drawing/2014/main" id="{C6E284FD-C2FA-B456-739C-7FAC9F506B47}"/>
+              </a:ext>
+            </a:extLst>
+          </p:cNvPr>
+          <p:cNvSpPr>
+            <a:spLocks noGrp="1"/>
+          </p:cNvSpPr>
+          <p:nvPr>
+            <p:ph type="title"/>
+          </p:nvPr>
+        </p:nvSpPr>
+        <p:spPr/>
+        <p:txBody>
+          <a:bodyPr>
+            <a:normAutofit fontScale="90000"/>
+          </a:bodyPr>
+          <a:lstStyle/>
+          <a:p>
+            <a:endParaRPr lang="en-GB"/>
+          </a:p>
+        </p:txBody>
+      </p:sp>
+      <p:sp>
+        <p:nvSpPr>
+          <p:cNvPr id="3" name="Text Placeholder 2">
+            <a:extLst>
+              <a:ext uri="{FF2B5EF4-FFF2-40B4-BE49-F238E27FC236}">
+                <a16:creationId xmlns:a16="http://schemas.microsoft.com/office/drawing/2014/main" id="{48943DF3-E2A2-BB3A-EF89-077A8E0020B3}"/>
+              </a:ext>
+            </a:extLst>
+          </p:cNvPr>
+          <p:cNvSpPr>
+            <a:spLocks noGrp="1"/>
+          </p:cNvSpPr>
+          <p:nvPr>
+            <p:ph type="body" idx="1"/>
+          </p:nvPr>
+        </p:nvSpPr>
+        <p:spPr/>
+        <p:txBody>
+          <a:bodyPr/>
+          <a:lstStyle/>
+          <a:p>
+            <a:endParaRPr lang="en-GB"/>
+          </a:p>
+        </p:txBody>
+      </p:sp>
+      <p:pic>
+        <p:nvPicPr>
+          <p:cNvPr id="6" name="Picture 5">
+            <a:extLst>
+              <a:ext uri="{FF2B5EF4-FFF2-40B4-BE49-F238E27FC236}">
+                <a16:creationId xmlns:a16="http://schemas.microsoft.com/office/drawing/2014/main" id="{0420441B-E511-F21C-751C-3590A9E2851F}"/>
+              </a:ext>
+            </a:extLst>
+          </p:cNvPr>
+          <p:cNvPicPr>
+            <a:picLocks noChangeAspect="1"/>
+          </p:cNvPicPr>
+          <p:nvPr/>
+        </p:nvPicPr>
+        <p:blipFill>
+          <a:blip r:embed="rId2"/>
+          <a:stretch>
+            <a:fillRect/>
+          </a:stretch>
+        </p:blipFill>
+        <p:spPr>
+          <a:xfrm>
+            <a:off x="0" y="236923"/>
+            <a:ext cx="9144000" cy="4527612"/>
+          </a:xfrm>
+          <a:prstGeom prst="rect">
+            <a:avLst/>
+          </a:prstGeom>
+        </p:spPr>
+      </p:pic>
+    </p:spTree>
+    <p:extLst>
+      <p:ext uri="{BB962C8B-B14F-4D97-AF65-F5344CB8AC3E}">
+        <p14:creationId xmlns:p14="http://schemas.microsoft.com/office/powerpoint/2010/main" val="3752679071"/>
+      </p:ext>
+    </p:extLst>
+  </p:cSld>
+  <p:clrMapOvr>
+    <a:masterClrMapping/>
+  </p:clrMapOvr>
+</p:sld>
+</file>
+
+<file path=ppt/slides/slide14.xml><?xml version="1.0" encoding="utf-8"?>
 <p:sld xmlns:a="http://schemas.openxmlformats.org/drawingml/2006/main" xmlns:r="http://schemas.openxmlformats.org/officeDocument/2006/relationships" xmlns:p="http://schemas.openxmlformats.org/presentationml/2006/main">
   <p:cSld>
     <p:spTree>
@@ -9104,7 +9336,7 @@
 </p:sld>
 </file>
 
-<file path=ppt/slides/slide13.xml><?xml version="1.0" encoding="utf-8"?>
+<file path=ppt/slides/slide15.xml><?xml version="1.0" encoding="utf-8"?>
 <p:sld xmlns:a="http://schemas.openxmlformats.org/drawingml/2006/main" xmlns:r="http://schemas.openxmlformats.org/officeDocument/2006/relationships" xmlns:p="http://schemas.openxmlformats.org/presentationml/2006/main">
   <p:cSld>
     <p:spTree>
@@ -9395,7 +9627,7 @@
 </p:sld>
 </file>
 
-<file path=ppt/slides/slide14.xml><?xml version="1.0" encoding="utf-8"?>
+<file path=ppt/slides/slide16.xml><?xml version="1.0" encoding="utf-8"?>
 <p:sld xmlns:a="http://schemas.openxmlformats.org/drawingml/2006/main" xmlns:r="http://schemas.openxmlformats.org/officeDocument/2006/relationships" xmlns:p="http://schemas.openxmlformats.org/presentationml/2006/main" show="0">
   <p:cSld>
     <p:spTree>
@@ -9650,7 +9882,7 @@
 </p:sld>
 </file>
 
-<file path=ppt/slides/slide15.xml><?xml version="1.0" encoding="utf-8"?>
+<file path=ppt/slides/slide17.xml><?xml version="1.0" encoding="utf-8"?>
 <p:sld xmlns:a="http://schemas.openxmlformats.org/drawingml/2006/main" xmlns:r="http://schemas.openxmlformats.org/officeDocument/2006/relationships" xmlns:p="http://schemas.openxmlformats.org/presentationml/2006/main">
   <p:cSld>
     <p:spTree>
@@ -10147,7 +10379,7 @@
 </p:sld>
 </file>
 
-<file path=ppt/slides/slide16.xml><?xml version="1.0" encoding="utf-8"?>
+<file path=ppt/slides/slide18.xml><?xml version="1.0" encoding="utf-8"?>
 <p:sld xmlns:a="http://schemas.openxmlformats.org/drawingml/2006/main" xmlns:r="http://schemas.openxmlformats.org/officeDocument/2006/relationships" xmlns:p="http://schemas.openxmlformats.org/presentationml/2006/main">
   <p:cSld>
     <p:spTree>
@@ -10798,7 +11030,7 @@
 </p:sld>
 </file>
 
-<file path=ppt/slides/slide17.xml><?xml version="1.0" encoding="utf-8"?>
+<file path=ppt/slides/slide19.xml><?xml version="1.0" encoding="utf-8"?>
 <p:sld xmlns:a="http://schemas.openxmlformats.org/drawingml/2006/main" xmlns:r="http://schemas.openxmlformats.org/officeDocument/2006/relationships" xmlns:p="http://schemas.openxmlformats.org/presentationml/2006/main">
   <p:cSld>
     <p:spTree>
@@ -11376,592 +11608,6 @@
 </p:sld>
 </file>
 
-<file path=ppt/slides/slide18.xml><?xml version="1.0" encoding="utf-8"?>
-<p:sld xmlns:a="http://schemas.openxmlformats.org/drawingml/2006/main" xmlns:r="http://schemas.openxmlformats.org/officeDocument/2006/relationships" xmlns:p="http://schemas.openxmlformats.org/presentationml/2006/main">
-  <p:cSld>
-    <p:spTree>
-      <p:nvGrpSpPr>
-        <p:cNvPr id="1" name=""/>
-        <p:cNvGrpSpPr/>
-        <p:nvPr/>
-      </p:nvGrpSpPr>
-      <p:grpSpPr>
-        <a:xfrm>
-          <a:off x="0" y="0"/>
-          <a:ext cx="0" cy="0"/>
-          <a:chOff x="0" y="0"/>
-          <a:chExt cx="0" cy="0"/>
-        </a:xfrm>
-      </p:grpSpPr>
-      <p:sp>
-        <p:nvSpPr>
-          <p:cNvPr id="65" name="Google Shape;65;p14"/>
-          <p:cNvSpPr/>
-          <p:nvPr/>
-        </p:nvSpPr>
-        <p:spPr>
-          <a:xfrm rot="10800000" flipH="1">
-            <a:off x="-9816" y="2428866"/>
-            <a:ext cx="9163638" cy="2714634"/>
-          </a:xfrm>
-          <a:prstGeom prst="flowChartDocument">
-            <a:avLst/>
-          </a:prstGeom>
-          <a:solidFill>
-            <a:srgbClr val="DEF5FF"/>
-          </a:solidFill>
-          <a:ln>
-            <a:noFill/>
-          </a:ln>
-        </p:spPr>
-        <p:txBody>
-          <a:bodyPr spcFirstLastPara="1" wrap="square" lIns="91425" tIns="91425" rIns="91425" bIns="91425" anchor="ctr" anchorCtr="0">
-            <a:noAutofit/>
-          </a:bodyPr>
-          <a:lstStyle/>
-          <a:p>
-            <a:pPr marL="0" lvl="0" indent="0" algn="ctr" rtl="0">
-              <a:spcBef>
-                <a:spcPts val="0"/>
-              </a:spcBef>
-              <a:spcAft>
-                <a:spcPts val="0"/>
-              </a:spcAft>
-              <a:buNone/>
-            </a:pPr>
-            <a:endParaRPr/>
-          </a:p>
-        </p:txBody>
-      </p:sp>
-      <p:pic>
-        <p:nvPicPr>
-          <p:cNvPr id="66" name="Google Shape;66;p14" title="Wave.png"/>
-          <p:cNvPicPr preferRelativeResize="0"/>
-          <p:nvPr/>
-        </p:nvPicPr>
-        <p:blipFill rotWithShape="1">
-          <a:blip r:embed="rId3">
-            <a:alphaModFix/>
-          </a:blip>
-          <a:srcRect l="1896" r="1886" b="28947"/>
-          <a:stretch/>
-        </p:blipFill>
-        <p:spPr>
-          <a:xfrm>
-            <a:off x="-3850" y="3455650"/>
-            <a:ext cx="9151677" cy="1687850"/>
-          </a:xfrm>
-          <a:prstGeom prst="rect">
-            <a:avLst/>
-          </a:prstGeom>
-          <a:noFill/>
-          <a:ln>
-            <a:noFill/>
-          </a:ln>
-        </p:spPr>
-      </p:pic>
-      <p:pic>
-        <p:nvPicPr>
-          <p:cNvPr id="67" name="Google Shape;67;p14" title="bubbles.png"/>
-          <p:cNvPicPr preferRelativeResize="0"/>
-          <p:nvPr/>
-        </p:nvPicPr>
-        <p:blipFill rotWithShape="1">
-          <a:blip r:embed="rId4">
-            <a:alphaModFix/>
-          </a:blip>
-          <a:srcRect l="40507" r="16342"/>
-          <a:stretch/>
-        </p:blipFill>
-        <p:spPr>
-          <a:xfrm rot="10800000">
-            <a:off x="8308600" y="1506410"/>
-            <a:ext cx="765850" cy="2013450"/>
-          </a:xfrm>
-          <a:prstGeom prst="rect">
-            <a:avLst/>
-          </a:prstGeom>
-          <a:noFill/>
-          <a:ln>
-            <a:noFill/>
-          </a:ln>
-        </p:spPr>
-      </p:pic>
-      <p:pic>
-        <p:nvPicPr>
-          <p:cNvPr id="68" name="Google Shape;68;p14" title="bubbles 2.png"/>
-          <p:cNvPicPr preferRelativeResize="0"/>
-          <p:nvPr/>
-        </p:nvPicPr>
-        <p:blipFill rotWithShape="1">
-          <a:blip r:embed="rId5">
-            <a:alphaModFix/>
-          </a:blip>
-          <a:srcRect l="15139" t="58400" r="62500" b="19350"/>
-          <a:stretch/>
-        </p:blipFill>
-        <p:spPr>
-          <a:xfrm rot="742639">
-            <a:off x="149255" y="3644868"/>
-            <a:ext cx="578386" cy="679568"/>
-          </a:xfrm>
-          <a:prstGeom prst="rect">
-            <a:avLst/>
-          </a:prstGeom>
-          <a:noFill/>
-          <a:ln>
-            <a:noFill/>
-          </a:ln>
-        </p:spPr>
-      </p:pic>
-      <p:pic>
-        <p:nvPicPr>
-          <p:cNvPr id="69" name="Google Shape;69;p14" title="bubbles 2.png"/>
-          <p:cNvPicPr preferRelativeResize="0"/>
-          <p:nvPr/>
-        </p:nvPicPr>
-        <p:blipFill rotWithShape="1">
-          <a:blip r:embed="rId5">
-            <a:alphaModFix/>
-          </a:blip>
-          <a:srcRect r="57354" b="65392"/>
-          <a:stretch/>
-        </p:blipFill>
-        <p:spPr>
-          <a:xfrm rot="-308349">
-            <a:off x="19632" y="2782409"/>
-            <a:ext cx="573357" cy="549431"/>
-          </a:xfrm>
-          <a:prstGeom prst="rect">
-            <a:avLst/>
-          </a:prstGeom>
-          <a:noFill/>
-          <a:ln>
-            <a:noFill/>
-          </a:ln>
-        </p:spPr>
-      </p:pic>
-      <p:pic>
-        <p:nvPicPr>
-          <p:cNvPr id="70" name="Google Shape;70;p14" title="Tentacles.png"/>
-          <p:cNvPicPr preferRelativeResize="0"/>
-          <p:nvPr/>
-        </p:nvPicPr>
-        <p:blipFill>
-          <a:blip r:embed="rId6">
-            <a:alphaModFix/>
-          </a:blip>
-          <a:stretch>
-            <a:fillRect/>
-          </a:stretch>
-        </p:blipFill>
-        <p:spPr>
-          <a:xfrm>
-            <a:off x="5864377" y="3364666"/>
-            <a:ext cx="3406625" cy="1787075"/>
-          </a:xfrm>
-          <a:prstGeom prst="rect">
-            <a:avLst/>
-          </a:prstGeom>
-          <a:noFill/>
-          <a:ln>
-            <a:noFill/>
-          </a:ln>
-        </p:spPr>
-      </p:pic>
-      <p:sp>
-        <p:nvSpPr>
-          <p:cNvPr id="71" name="Google Shape;71;p14"/>
-          <p:cNvSpPr txBox="1">
-            <a:spLocks noGrp="1"/>
-          </p:cNvSpPr>
-          <p:nvPr>
-            <p:ph type="ctrTitle"/>
-          </p:nvPr>
-        </p:nvSpPr>
-        <p:spPr>
-          <a:xfrm>
-            <a:off x="311700" y="744575"/>
-            <a:ext cx="8520600" cy="1446300"/>
-          </a:xfrm>
-          <a:prstGeom prst="rect">
-            <a:avLst/>
-          </a:prstGeom>
-        </p:spPr>
-        <p:txBody>
-          <a:bodyPr spcFirstLastPara="1" wrap="square" lIns="91425" tIns="91425" rIns="91425" bIns="91425" anchor="b" anchorCtr="0">
-            <a:normAutofit/>
-          </a:bodyPr>
-          <a:lstStyle/>
-          <a:p>
-            <a:pPr marL="0" lvl="0" indent="0" algn="l" rtl="0">
-              <a:spcBef>
-                <a:spcPts val="0"/>
-              </a:spcBef>
-              <a:spcAft>
-                <a:spcPts val="0"/>
-              </a:spcAft>
-              <a:buNone/>
-            </a:pPr>
-            <a:r>
-              <a:rPr sz="4000" b="1" dirty="0">
-                <a:solidFill>
-                  <a:srgbClr val="10265D"/>
-                </a:solidFill>
-                <a:latin typeface="Etna"/>
-              </a:rPr>
-              <a:t>Demo: </a:t>
-            </a:r>
-            <a:r>
-              <a:rPr lang="en-GB" sz="4000" b="1" dirty="0">
-                <a:solidFill>
-                  <a:srgbClr val="10265D"/>
-                </a:solidFill>
-                <a:latin typeface="Etna"/>
-              </a:rPr>
-              <a:t>dab in 2 mins</a:t>
-            </a:r>
-            <a:endParaRPr dirty="0"/>
-          </a:p>
-        </p:txBody>
-      </p:sp>
-    </p:spTree>
-  </p:cSld>
-  <p:clrMapOvr>
-    <a:masterClrMapping/>
-  </p:clrMapOvr>
-</p:sld>
-</file>
-
-<file path=ppt/slides/slide19.xml><?xml version="1.0" encoding="utf-8"?>
-<p:sld xmlns:a="http://schemas.openxmlformats.org/drawingml/2006/main" xmlns:r="http://schemas.openxmlformats.org/officeDocument/2006/relationships" xmlns:p="http://schemas.openxmlformats.org/presentationml/2006/main" show="0">
-  <p:cSld>
-    <p:spTree>
-      <p:nvGrpSpPr>
-        <p:cNvPr id="1" name=""/>
-        <p:cNvGrpSpPr/>
-        <p:nvPr/>
-      </p:nvGrpSpPr>
-      <p:grpSpPr>
-        <a:xfrm>
-          <a:off x="0" y="0"/>
-          <a:ext cx="0" cy="0"/>
-          <a:chOff x="0" y="0"/>
-          <a:chExt cx="0" cy="0"/>
-        </a:xfrm>
-      </p:grpSpPr>
-      <p:pic>
-        <p:nvPicPr>
-          <p:cNvPr id="76" name="Google Shape;76;p15" title="Wave.png"/>
-          <p:cNvPicPr preferRelativeResize="0"/>
-          <p:nvPr/>
-        </p:nvPicPr>
-        <p:blipFill rotWithShape="1">
-          <a:blip r:embed="rId3">
-            <a:alphaModFix amt="50000"/>
-          </a:blip>
-          <a:srcRect l="1876" r="1905" b="34193"/>
-          <a:stretch/>
-        </p:blipFill>
-        <p:spPr>
-          <a:xfrm>
-            <a:off x="-3850" y="3580350"/>
-            <a:ext cx="9151677" cy="1563150"/>
-          </a:xfrm>
-          <a:prstGeom prst="rect">
-            <a:avLst/>
-          </a:prstGeom>
-          <a:noFill/>
-          <a:ln>
-            <a:noFill/>
-          </a:ln>
-        </p:spPr>
-      </p:pic>
-      <p:pic>
-        <p:nvPicPr>
-          <p:cNvPr id="77" name="Google Shape;77;p15" title="bubbles 2.png"/>
-          <p:cNvPicPr preferRelativeResize="0"/>
-          <p:nvPr/>
-        </p:nvPicPr>
-        <p:blipFill rotWithShape="1">
-          <a:blip r:embed="rId4">
-            <a:alphaModFix/>
-          </a:blip>
-          <a:srcRect l="15139" t="47353" r="57355" b="19349"/>
-          <a:stretch/>
-        </p:blipFill>
-        <p:spPr>
-          <a:xfrm rot="742634">
-            <a:off x="183865" y="3325606"/>
-            <a:ext cx="711448" cy="1017014"/>
-          </a:xfrm>
-          <a:prstGeom prst="rect">
-            <a:avLst/>
-          </a:prstGeom>
-          <a:noFill/>
-          <a:ln>
-            <a:noFill/>
-          </a:ln>
-        </p:spPr>
-      </p:pic>
-      <p:pic>
-        <p:nvPicPr>
-          <p:cNvPr id="78" name="Google Shape;78;p15" title="bubbles.png"/>
-          <p:cNvPicPr preferRelativeResize="0"/>
-          <p:nvPr/>
-        </p:nvPicPr>
-        <p:blipFill rotWithShape="1">
-          <a:blip r:embed="rId5">
-            <a:alphaModFix/>
-          </a:blip>
-          <a:srcRect l="40507" r="16342"/>
-          <a:stretch/>
-        </p:blipFill>
-        <p:spPr>
-          <a:xfrm>
-            <a:off x="8240407" y="2165913"/>
-            <a:ext cx="907418" cy="2385675"/>
-          </a:xfrm>
-          <a:prstGeom prst="rect">
-            <a:avLst/>
-          </a:prstGeom>
-          <a:noFill/>
-          <a:ln>
-            <a:noFill/>
-          </a:ln>
-        </p:spPr>
-      </p:pic>
-      <p:pic>
-        <p:nvPicPr>
-          <p:cNvPr id="79" name="Google Shape;79;p15" title="bubbles 2.png"/>
-          <p:cNvPicPr preferRelativeResize="0"/>
-          <p:nvPr/>
-        </p:nvPicPr>
-        <p:blipFill rotWithShape="1">
-          <a:blip r:embed="rId4">
-            <a:alphaModFix/>
-          </a:blip>
-          <a:srcRect r="57354" b="65392"/>
-          <a:stretch/>
-        </p:blipFill>
-        <p:spPr>
-          <a:xfrm rot="-308349">
-            <a:off x="252920" y="2687159"/>
-            <a:ext cx="573357" cy="549431"/>
-          </a:xfrm>
-          <a:prstGeom prst="rect">
-            <a:avLst/>
-          </a:prstGeom>
-          <a:noFill/>
-          <a:ln>
-            <a:noFill/>
-          </a:ln>
-        </p:spPr>
-      </p:pic>
-      <p:pic>
-        <p:nvPicPr>
-          <p:cNvPr id="80" name="Google Shape;80;p15" title="Tentacles.png"/>
-          <p:cNvPicPr preferRelativeResize="0"/>
-          <p:nvPr/>
-        </p:nvPicPr>
-        <p:blipFill>
-          <a:blip r:embed="rId6">
-            <a:alphaModFix/>
-          </a:blip>
-          <a:stretch>
-            <a:fillRect/>
-          </a:stretch>
-        </p:blipFill>
-        <p:spPr>
-          <a:xfrm>
-            <a:off x="6310958" y="3580350"/>
-            <a:ext cx="2979741" cy="1563150"/>
-          </a:xfrm>
-          <a:prstGeom prst="rect">
-            <a:avLst/>
-          </a:prstGeom>
-          <a:noFill/>
-          <a:ln>
-            <a:noFill/>
-          </a:ln>
-        </p:spPr>
-      </p:pic>
-      <p:sp>
-        <p:nvSpPr>
-          <p:cNvPr id="81" name="TextBox 80"/>
-          <p:cNvSpPr txBox="1"/>
-          <p:nvPr/>
-        </p:nvSpPr>
-        <p:spPr>
-          <a:xfrm>
-            <a:off x="311700" y="350000"/>
-            <a:ext cx="8520600" cy="1050000"/>
-          </a:xfrm>
-          <a:prstGeom prst="rect">
-            <a:avLst/>
-          </a:prstGeom>
-          <a:noFill/>
-        </p:spPr>
-        <p:txBody>
-          <a:bodyPr wrap="square" lIns="0" tIns="0" rIns="0" bIns="0" anchor="t">
-            <a:spAutoFit/>
-          </a:bodyPr>
-          <a:lstStyle/>
-          <a:p>
-            <a:pPr algn="l"/>
-            <a:r>
-              <a:rPr sz="3600" b="1">
-                <a:solidFill>
-                  <a:srgbClr val="10265D"/>
-                </a:solidFill>
-                <a:latin typeface="Etna"/>
-              </a:rPr>
-              <a:t>Filter, page, relate</a:t>
-            </a:r>
-          </a:p>
-        </p:txBody>
-      </p:sp>
-      <p:sp>
-        <p:nvSpPr>
-          <p:cNvPr id="82" name="TextBox 81"/>
-          <p:cNvSpPr txBox="1"/>
-          <p:nvPr/>
-        </p:nvSpPr>
-        <p:spPr>
-          <a:xfrm>
-            <a:off x="311700" y="1500000"/>
-            <a:ext cx="8520600" cy="2000000"/>
-          </a:xfrm>
-          <a:prstGeom prst="rect">
-            <a:avLst/>
-          </a:prstGeom>
-          <a:noFill/>
-        </p:spPr>
-        <p:txBody>
-          <a:bodyPr wrap="square" lIns="0" tIns="0" rIns="0" bIns="0" anchor="t">
-            <a:spAutoFit/>
-          </a:bodyPr>
-          <a:lstStyle/>
-          <a:p>
-            <a:pPr algn="l">
-              <a:spcAft>
-                <a:spcPts val="600"/>
-              </a:spcAft>
-            </a:pPr>
-            <a:r>
-              <a:rPr sz="2000" b="0">
-                <a:solidFill>
-                  <a:srgbClr val="1A1A1A"/>
-                </a:solidFill>
-                <a:latin typeface="Garet"/>
-              </a:rPr>
-              <a:t>Filter via query string — $filter, $select.</a:t>
-            </a:r>
-          </a:p>
-          <a:p>
-            <a:pPr algn="l">
-              <a:spcAft>
-                <a:spcPts val="600"/>
-              </a:spcAft>
-            </a:pPr>
-            <a:r>
-              <a:rPr sz="2000" b="0">
-                <a:solidFill>
-                  <a:srgbClr val="1A1A1A"/>
-                </a:solidFill>
-                <a:latin typeface="Garet"/>
-              </a:rPr>
-              <a:t>Paginate — $first, $after.</a:t>
-            </a:r>
-          </a:p>
-          <a:p>
-            <a:pPr algn="l">
-              <a:spcAft>
-                <a:spcPts val="600"/>
-              </a:spcAft>
-            </a:pPr>
-            <a:r>
-              <a:rPr sz="2000" b="0">
-                <a:solidFill>
-                  <a:srgbClr val="1A1A1A"/>
-                </a:solidFill>
-                <a:latin typeface="Garet"/>
-              </a:rPr>
-              <a:t>Express relationships in the config — get nested data in one call.</a:t>
-            </a:r>
-          </a:p>
-          <a:p>
-            <a:pPr algn="l">
-              <a:spcAft>
-                <a:spcPts val="600"/>
-              </a:spcAft>
-            </a:pPr>
-            <a:r>
-              <a:rPr sz="2000" b="0">
-                <a:solidFill>
-                  <a:srgbClr val="1A1A1A"/>
-                </a:solidFill>
-                <a:latin typeface="Garet"/>
-              </a:rPr>
-              <a:t>Or use the GraphQL endpoint and ask for exactly what you need.</a:t>
-            </a:r>
-          </a:p>
-        </p:txBody>
-      </p:sp>
-      <p:sp>
-        <p:nvSpPr>
-          <p:cNvPr id="83" name="TextBox 82"/>
-          <p:cNvSpPr txBox="1"/>
-          <p:nvPr/>
-        </p:nvSpPr>
-        <p:spPr>
-          <a:xfrm>
-            <a:off x="311700" y="2700000"/>
-            <a:ext cx="8520600" cy="600000"/>
-          </a:xfrm>
-          <a:prstGeom prst="rect">
-            <a:avLst/>
-          </a:prstGeom>
-          <a:solidFill>
-            <a:srgbClr val="F4F7FB"/>
-          </a:solidFill>
-          <a:ln>
-            <a:solidFill>
-              <a:srgbClr val="BDECFE"/>
-            </a:solidFill>
-          </a:ln>
-        </p:spPr>
-        <p:txBody>
-          <a:bodyPr wrap="square" lIns="120000" tIns="80000" rIns="120000" bIns="80000">
-            <a:spAutoFit/>
-          </a:bodyPr>
-          <a:lstStyle/>
-          <a:p>
-            <a:pPr algn="l">
-              <a:spcAft>
-                <a:spcPts val="0"/>
-              </a:spcAft>
-            </a:pPr>
-            <a:r>
-              <a:rPr sz="1300">
-                <a:solidFill>
-                  <a:srgbClr val="10265D"/>
-                </a:solidFill>
-                <a:latin typeface="Cascadia Mono"/>
-              </a:rPr>
-              <a:t>GET /api/Activity?$filter=type eq 'Ride'&amp;$first=10&amp;$select=date,distance,tss</a:t>
-            </a:r>
-          </a:p>
-        </p:txBody>
-      </p:sp>
-    </p:spTree>
-  </p:cSld>
-  <p:clrMapOvr>
-    <a:masterClrMapping/>
-  </p:clrMapOvr>
-</p:sld>
-</file>
-
 <file path=ppt/slides/slide2.xml><?xml version="1.0" encoding="utf-8"?>
 <p:sld xmlns:a="http://schemas.openxmlformats.org/drawingml/2006/main" xmlns:r="http://schemas.openxmlformats.org/officeDocument/2006/relationships" xmlns:p="http://schemas.openxmlformats.org/presentationml/2006/main">
   <p:cSld>
@@ -12486,6 +12132,592 @@
           <a:chExt cx="0" cy="0"/>
         </a:xfrm>
       </p:grpSpPr>
+      <p:sp>
+        <p:nvSpPr>
+          <p:cNvPr id="65" name="Google Shape;65;p14"/>
+          <p:cNvSpPr/>
+          <p:nvPr/>
+        </p:nvSpPr>
+        <p:spPr>
+          <a:xfrm rot="10800000" flipH="1">
+            <a:off x="-9816" y="2428866"/>
+            <a:ext cx="9163638" cy="2714634"/>
+          </a:xfrm>
+          <a:prstGeom prst="flowChartDocument">
+            <a:avLst/>
+          </a:prstGeom>
+          <a:solidFill>
+            <a:srgbClr val="DEF5FF"/>
+          </a:solidFill>
+          <a:ln>
+            <a:noFill/>
+          </a:ln>
+        </p:spPr>
+        <p:txBody>
+          <a:bodyPr spcFirstLastPara="1" wrap="square" lIns="91425" tIns="91425" rIns="91425" bIns="91425" anchor="ctr" anchorCtr="0">
+            <a:noAutofit/>
+          </a:bodyPr>
+          <a:lstStyle/>
+          <a:p>
+            <a:pPr marL="0" lvl="0" indent="0" algn="ctr" rtl="0">
+              <a:spcBef>
+                <a:spcPts val="0"/>
+              </a:spcBef>
+              <a:spcAft>
+                <a:spcPts val="0"/>
+              </a:spcAft>
+              <a:buNone/>
+            </a:pPr>
+            <a:endParaRPr/>
+          </a:p>
+        </p:txBody>
+      </p:sp>
+      <p:pic>
+        <p:nvPicPr>
+          <p:cNvPr id="66" name="Google Shape;66;p14" title="Wave.png"/>
+          <p:cNvPicPr preferRelativeResize="0"/>
+          <p:nvPr/>
+        </p:nvPicPr>
+        <p:blipFill rotWithShape="1">
+          <a:blip r:embed="rId3">
+            <a:alphaModFix/>
+          </a:blip>
+          <a:srcRect l="1896" r="1886" b="28947"/>
+          <a:stretch/>
+        </p:blipFill>
+        <p:spPr>
+          <a:xfrm>
+            <a:off x="-3850" y="3455650"/>
+            <a:ext cx="9151677" cy="1687850"/>
+          </a:xfrm>
+          <a:prstGeom prst="rect">
+            <a:avLst/>
+          </a:prstGeom>
+          <a:noFill/>
+          <a:ln>
+            <a:noFill/>
+          </a:ln>
+        </p:spPr>
+      </p:pic>
+      <p:pic>
+        <p:nvPicPr>
+          <p:cNvPr id="67" name="Google Shape;67;p14" title="bubbles.png"/>
+          <p:cNvPicPr preferRelativeResize="0"/>
+          <p:nvPr/>
+        </p:nvPicPr>
+        <p:blipFill rotWithShape="1">
+          <a:blip r:embed="rId4">
+            <a:alphaModFix/>
+          </a:blip>
+          <a:srcRect l="40507" r="16342"/>
+          <a:stretch/>
+        </p:blipFill>
+        <p:spPr>
+          <a:xfrm rot="10800000">
+            <a:off x="8308600" y="1506410"/>
+            <a:ext cx="765850" cy="2013450"/>
+          </a:xfrm>
+          <a:prstGeom prst="rect">
+            <a:avLst/>
+          </a:prstGeom>
+          <a:noFill/>
+          <a:ln>
+            <a:noFill/>
+          </a:ln>
+        </p:spPr>
+      </p:pic>
+      <p:pic>
+        <p:nvPicPr>
+          <p:cNvPr id="68" name="Google Shape;68;p14" title="bubbles 2.png"/>
+          <p:cNvPicPr preferRelativeResize="0"/>
+          <p:nvPr/>
+        </p:nvPicPr>
+        <p:blipFill rotWithShape="1">
+          <a:blip r:embed="rId5">
+            <a:alphaModFix/>
+          </a:blip>
+          <a:srcRect l="15139" t="58400" r="62500" b="19350"/>
+          <a:stretch/>
+        </p:blipFill>
+        <p:spPr>
+          <a:xfrm rot="742639">
+            <a:off x="149255" y="3644868"/>
+            <a:ext cx="578386" cy="679568"/>
+          </a:xfrm>
+          <a:prstGeom prst="rect">
+            <a:avLst/>
+          </a:prstGeom>
+          <a:noFill/>
+          <a:ln>
+            <a:noFill/>
+          </a:ln>
+        </p:spPr>
+      </p:pic>
+      <p:pic>
+        <p:nvPicPr>
+          <p:cNvPr id="69" name="Google Shape;69;p14" title="bubbles 2.png"/>
+          <p:cNvPicPr preferRelativeResize="0"/>
+          <p:nvPr/>
+        </p:nvPicPr>
+        <p:blipFill rotWithShape="1">
+          <a:blip r:embed="rId5">
+            <a:alphaModFix/>
+          </a:blip>
+          <a:srcRect r="57354" b="65392"/>
+          <a:stretch/>
+        </p:blipFill>
+        <p:spPr>
+          <a:xfrm rot="-308349">
+            <a:off x="19632" y="2782409"/>
+            <a:ext cx="573357" cy="549431"/>
+          </a:xfrm>
+          <a:prstGeom prst="rect">
+            <a:avLst/>
+          </a:prstGeom>
+          <a:noFill/>
+          <a:ln>
+            <a:noFill/>
+          </a:ln>
+        </p:spPr>
+      </p:pic>
+      <p:pic>
+        <p:nvPicPr>
+          <p:cNvPr id="70" name="Google Shape;70;p14" title="Tentacles.png"/>
+          <p:cNvPicPr preferRelativeResize="0"/>
+          <p:nvPr/>
+        </p:nvPicPr>
+        <p:blipFill>
+          <a:blip r:embed="rId6">
+            <a:alphaModFix/>
+          </a:blip>
+          <a:stretch>
+            <a:fillRect/>
+          </a:stretch>
+        </p:blipFill>
+        <p:spPr>
+          <a:xfrm>
+            <a:off x="5864377" y="3364666"/>
+            <a:ext cx="3406625" cy="1787075"/>
+          </a:xfrm>
+          <a:prstGeom prst="rect">
+            <a:avLst/>
+          </a:prstGeom>
+          <a:noFill/>
+          <a:ln>
+            <a:noFill/>
+          </a:ln>
+        </p:spPr>
+      </p:pic>
+      <p:sp>
+        <p:nvSpPr>
+          <p:cNvPr id="71" name="Google Shape;71;p14"/>
+          <p:cNvSpPr txBox="1">
+            <a:spLocks noGrp="1"/>
+          </p:cNvSpPr>
+          <p:nvPr>
+            <p:ph type="ctrTitle"/>
+          </p:nvPr>
+        </p:nvSpPr>
+        <p:spPr>
+          <a:xfrm>
+            <a:off x="311700" y="744575"/>
+            <a:ext cx="8520600" cy="1446300"/>
+          </a:xfrm>
+          <a:prstGeom prst="rect">
+            <a:avLst/>
+          </a:prstGeom>
+        </p:spPr>
+        <p:txBody>
+          <a:bodyPr spcFirstLastPara="1" wrap="square" lIns="91425" tIns="91425" rIns="91425" bIns="91425" anchor="b" anchorCtr="0">
+            <a:normAutofit/>
+          </a:bodyPr>
+          <a:lstStyle/>
+          <a:p>
+            <a:pPr marL="0" lvl="0" indent="0" algn="l" rtl="0">
+              <a:spcBef>
+                <a:spcPts val="0"/>
+              </a:spcBef>
+              <a:spcAft>
+                <a:spcPts val="0"/>
+              </a:spcAft>
+              <a:buNone/>
+            </a:pPr>
+            <a:r>
+              <a:rPr sz="4000" b="1" dirty="0">
+                <a:solidFill>
+                  <a:srgbClr val="10265D"/>
+                </a:solidFill>
+                <a:latin typeface="Etna"/>
+              </a:rPr>
+              <a:t>Demo: </a:t>
+            </a:r>
+            <a:r>
+              <a:rPr lang="en-GB" sz="4000" b="1" dirty="0">
+                <a:solidFill>
+                  <a:srgbClr val="10265D"/>
+                </a:solidFill>
+                <a:latin typeface="Etna"/>
+              </a:rPr>
+              <a:t>dab in 2 mins</a:t>
+            </a:r>
+            <a:endParaRPr dirty="0"/>
+          </a:p>
+        </p:txBody>
+      </p:sp>
+    </p:spTree>
+  </p:cSld>
+  <p:clrMapOvr>
+    <a:masterClrMapping/>
+  </p:clrMapOvr>
+</p:sld>
+</file>
+
+<file path=ppt/slides/slide21.xml><?xml version="1.0" encoding="utf-8"?>
+<p:sld xmlns:a="http://schemas.openxmlformats.org/drawingml/2006/main" xmlns:r="http://schemas.openxmlformats.org/officeDocument/2006/relationships" xmlns:p="http://schemas.openxmlformats.org/presentationml/2006/main" show="0">
+  <p:cSld>
+    <p:spTree>
+      <p:nvGrpSpPr>
+        <p:cNvPr id="1" name=""/>
+        <p:cNvGrpSpPr/>
+        <p:nvPr/>
+      </p:nvGrpSpPr>
+      <p:grpSpPr>
+        <a:xfrm>
+          <a:off x="0" y="0"/>
+          <a:ext cx="0" cy="0"/>
+          <a:chOff x="0" y="0"/>
+          <a:chExt cx="0" cy="0"/>
+        </a:xfrm>
+      </p:grpSpPr>
+      <p:pic>
+        <p:nvPicPr>
+          <p:cNvPr id="76" name="Google Shape;76;p15" title="Wave.png"/>
+          <p:cNvPicPr preferRelativeResize="0"/>
+          <p:nvPr/>
+        </p:nvPicPr>
+        <p:blipFill rotWithShape="1">
+          <a:blip r:embed="rId3">
+            <a:alphaModFix amt="50000"/>
+          </a:blip>
+          <a:srcRect l="1876" r="1905" b="34193"/>
+          <a:stretch/>
+        </p:blipFill>
+        <p:spPr>
+          <a:xfrm>
+            <a:off x="-3850" y="3580350"/>
+            <a:ext cx="9151677" cy="1563150"/>
+          </a:xfrm>
+          <a:prstGeom prst="rect">
+            <a:avLst/>
+          </a:prstGeom>
+          <a:noFill/>
+          <a:ln>
+            <a:noFill/>
+          </a:ln>
+        </p:spPr>
+      </p:pic>
+      <p:pic>
+        <p:nvPicPr>
+          <p:cNvPr id="77" name="Google Shape;77;p15" title="bubbles 2.png"/>
+          <p:cNvPicPr preferRelativeResize="0"/>
+          <p:nvPr/>
+        </p:nvPicPr>
+        <p:blipFill rotWithShape="1">
+          <a:blip r:embed="rId4">
+            <a:alphaModFix/>
+          </a:blip>
+          <a:srcRect l="15139" t="47353" r="57355" b="19349"/>
+          <a:stretch/>
+        </p:blipFill>
+        <p:spPr>
+          <a:xfrm rot="742634">
+            <a:off x="183865" y="3325606"/>
+            <a:ext cx="711448" cy="1017014"/>
+          </a:xfrm>
+          <a:prstGeom prst="rect">
+            <a:avLst/>
+          </a:prstGeom>
+          <a:noFill/>
+          <a:ln>
+            <a:noFill/>
+          </a:ln>
+        </p:spPr>
+      </p:pic>
+      <p:pic>
+        <p:nvPicPr>
+          <p:cNvPr id="78" name="Google Shape;78;p15" title="bubbles.png"/>
+          <p:cNvPicPr preferRelativeResize="0"/>
+          <p:nvPr/>
+        </p:nvPicPr>
+        <p:blipFill rotWithShape="1">
+          <a:blip r:embed="rId5">
+            <a:alphaModFix/>
+          </a:blip>
+          <a:srcRect l="40507" r="16342"/>
+          <a:stretch/>
+        </p:blipFill>
+        <p:spPr>
+          <a:xfrm>
+            <a:off x="8240407" y="2165913"/>
+            <a:ext cx="907418" cy="2385675"/>
+          </a:xfrm>
+          <a:prstGeom prst="rect">
+            <a:avLst/>
+          </a:prstGeom>
+          <a:noFill/>
+          <a:ln>
+            <a:noFill/>
+          </a:ln>
+        </p:spPr>
+      </p:pic>
+      <p:pic>
+        <p:nvPicPr>
+          <p:cNvPr id="79" name="Google Shape;79;p15" title="bubbles 2.png"/>
+          <p:cNvPicPr preferRelativeResize="0"/>
+          <p:nvPr/>
+        </p:nvPicPr>
+        <p:blipFill rotWithShape="1">
+          <a:blip r:embed="rId4">
+            <a:alphaModFix/>
+          </a:blip>
+          <a:srcRect r="57354" b="65392"/>
+          <a:stretch/>
+        </p:blipFill>
+        <p:spPr>
+          <a:xfrm rot="-308349">
+            <a:off x="252920" y="2687159"/>
+            <a:ext cx="573357" cy="549431"/>
+          </a:xfrm>
+          <a:prstGeom prst="rect">
+            <a:avLst/>
+          </a:prstGeom>
+          <a:noFill/>
+          <a:ln>
+            <a:noFill/>
+          </a:ln>
+        </p:spPr>
+      </p:pic>
+      <p:pic>
+        <p:nvPicPr>
+          <p:cNvPr id="80" name="Google Shape;80;p15" title="Tentacles.png"/>
+          <p:cNvPicPr preferRelativeResize="0"/>
+          <p:nvPr/>
+        </p:nvPicPr>
+        <p:blipFill>
+          <a:blip r:embed="rId6">
+            <a:alphaModFix/>
+          </a:blip>
+          <a:stretch>
+            <a:fillRect/>
+          </a:stretch>
+        </p:blipFill>
+        <p:spPr>
+          <a:xfrm>
+            <a:off x="6310958" y="3580350"/>
+            <a:ext cx="2979741" cy="1563150"/>
+          </a:xfrm>
+          <a:prstGeom prst="rect">
+            <a:avLst/>
+          </a:prstGeom>
+          <a:noFill/>
+          <a:ln>
+            <a:noFill/>
+          </a:ln>
+        </p:spPr>
+      </p:pic>
+      <p:sp>
+        <p:nvSpPr>
+          <p:cNvPr id="81" name="TextBox 80"/>
+          <p:cNvSpPr txBox="1"/>
+          <p:nvPr/>
+        </p:nvSpPr>
+        <p:spPr>
+          <a:xfrm>
+            <a:off x="311700" y="350000"/>
+            <a:ext cx="8520600" cy="1050000"/>
+          </a:xfrm>
+          <a:prstGeom prst="rect">
+            <a:avLst/>
+          </a:prstGeom>
+          <a:noFill/>
+        </p:spPr>
+        <p:txBody>
+          <a:bodyPr wrap="square" lIns="0" tIns="0" rIns="0" bIns="0" anchor="t">
+            <a:spAutoFit/>
+          </a:bodyPr>
+          <a:lstStyle/>
+          <a:p>
+            <a:pPr algn="l"/>
+            <a:r>
+              <a:rPr sz="3600" b="1">
+                <a:solidFill>
+                  <a:srgbClr val="10265D"/>
+                </a:solidFill>
+                <a:latin typeface="Etna"/>
+              </a:rPr>
+              <a:t>Filter, page, relate</a:t>
+            </a:r>
+          </a:p>
+        </p:txBody>
+      </p:sp>
+      <p:sp>
+        <p:nvSpPr>
+          <p:cNvPr id="82" name="TextBox 81"/>
+          <p:cNvSpPr txBox="1"/>
+          <p:nvPr/>
+        </p:nvSpPr>
+        <p:spPr>
+          <a:xfrm>
+            <a:off x="311700" y="1500000"/>
+            <a:ext cx="8520600" cy="2000000"/>
+          </a:xfrm>
+          <a:prstGeom prst="rect">
+            <a:avLst/>
+          </a:prstGeom>
+          <a:noFill/>
+        </p:spPr>
+        <p:txBody>
+          <a:bodyPr wrap="square" lIns="0" tIns="0" rIns="0" bIns="0" anchor="t">
+            <a:spAutoFit/>
+          </a:bodyPr>
+          <a:lstStyle/>
+          <a:p>
+            <a:pPr algn="l">
+              <a:spcAft>
+                <a:spcPts val="600"/>
+              </a:spcAft>
+            </a:pPr>
+            <a:r>
+              <a:rPr sz="2000" b="0">
+                <a:solidFill>
+                  <a:srgbClr val="1A1A1A"/>
+                </a:solidFill>
+                <a:latin typeface="Garet"/>
+              </a:rPr>
+              <a:t>Filter via query string — $filter, $select.</a:t>
+            </a:r>
+          </a:p>
+          <a:p>
+            <a:pPr algn="l">
+              <a:spcAft>
+                <a:spcPts val="600"/>
+              </a:spcAft>
+            </a:pPr>
+            <a:r>
+              <a:rPr sz="2000" b="0">
+                <a:solidFill>
+                  <a:srgbClr val="1A1A1A"/>
+                </a:solidFill>
+                <a:latin typeface="Garet"/>
+              </a:rPr>
+              <a:t>Paginate — $first, $after.</a:t>
+            </a:r>
+          </a:p>
+          <a:p>
+            <a:pPr algn="l">
+              <a:spcAft>
+                <a:spcPts val="600"/>
+              </a:spcAft>
+            </a:pPr>
+            <a:r>
+              <a:rPr sz="2000" b="0">
+                <a:solidFill>
+                  <a:srgbClr val="1A1A1A"/>
+                </a:solidFill>
+                <a:latin typeface="Garet"/>
+              </a:rPr>
+              <a:t>Express relationships in the config — get nested data in one call.</a:t>
+            </a:r>
+          </a:p>
+          <a:p>
+            <a:pPr algn="l">
+              <a:spcAft>
+                <a:spcPts val="600"/>
+              </a:spcAft>
+            </a:pPr>
+            <a:r>
+              <a:rPr sz="2000" b="0">
+                <a:solidFill>
+                  <a:srgbClr val="1A1A1A"/>
+                </a:solidFill>
+                <a:latin typeface="Garet"/>
+              </a:rPr>
+              <a:t>Or use the GraphQL endpoint and ask for exactly what you need.</a:t>
+            </a:r>
+          </a:p>
+        </p:txBody>
+      </p:sp>
+      <p:sp>
+        <p:nvSpPr>
+          <p:cNvPr id="83" name="TextBox 82"/>
+          <p:cNvSpPr txBox="1"/>
+          <p:nvPr/>
+        </p:nvSpPr>
+        <p:spPr>
+          <a:xfrm>
+            <a:off x="311700" y="2700000"/>
+            <a:ext cx="8520600" cy="600000"/>
+          </a:xfrm>
+          <a:prstGeom prst="rect">
+            <a:avLst/>
+          </a:prstGeom>
+          <a:solidFill>
+            <a:srgbClr val="F4F7FB"/>
+          </a:solidFill>
+          <a:ln>
+            <a:solidFill>
+              <a:srgbClr val="BDECFE"/>
+            </a:solidFill>
+          </a:ln>
+        </p:spPr>
+        <p:txBody>
+          <a:bodyPr wrap="square" lIns="120000" tIns="80000" rIns="120000" bIns="80000">
+            <a:spAutoFit/>
+          </a:bodyPr>
+          <a:lstStyle/>
+          <a:p>
+            <a:pPr algn="l">
+              <a:spcAft>
+                <a:spcPts val="0"/>
+              </a:spcAft>
+            </a:pPr>
+            <a:r>
+              <a:rPr sz="1300">
+                <a:solidFill>
+                  <a:srgbClr val="10265D"/>
+                </a:solidFill>
+                <a:latin typeface="Cascadia Mono"/>
+              </a:rPr>
+              <a:t>GET /api/Activity?$filter=type eq 'Ride'&amp;$first=10&amp;$select=date,distance,tss</a:t>
+            </a:r>
+          </a:p>
+        </p:txBody>
+      </p:sp>
+    </p:spTree>
+  </p:cSld>
+  <p:clrMapOvr>
+    <a:masterClrMapping/>
+  </p:clrMapOvr>
+</p:sld>
+</file>
+
+<file path=ppt/slides/slide22.xml><?xml version="1.0" encoding="utf-8"?>
+<p:sld xmlns:a="http://schemas.openxmlformats.org/drawingml/2006/main" xmlns:r="http://schemas.openxmlformats.org/officeDocument/2006/relationships" xmlns:p="http://schemas.openxmlformats.org/presentationml/2006/main">
+  <p:cSld>
+    <p:spTree>
+      <p:nvGrpSpPr>
+        <p:cNvPr id="1" name=""/>
+        <p:cNvGrpSpPr/>
+        <p:nvPr/>
+      </p:nvGrpSpPr>
+      <p:grpSpPr>
+        <a:xfrm>
+          <a:off x="0" y="0"/>
+          <a:ext cx="0" cy="0"/>
+          <a:chOff x="0" y="0"/>
+          <a:chExt cx="0" cy="0"/>
+        </a:xfrm>
+      </p:grpSpPr>
       <p:pic>
         <p:nvPicPr>
           <p:cNvPr id="85" name="Google Shape;85;p16" title="Wave.png"/>
@@ -12971,7 +13203,7 @@
 </p:sld>
 </file>
 
-<file path=ppt/slides/slide21.xml><?xml version="1.0" encoding="utf-8"?>
+<file path=ppt/slides/slide23.xml><?xml version="1.0" encoding="utf-8"?>
 <p:sld xmlns:a="http://schemas.openxmlformats.org/drawingml/2006/main" xmlns:r="http://schemas.openxmlformats.org/officeDocument/2006/relationships" xmlns:p="http://schemas.openxmlformats.org/presentationml/2006/main">
   <p:cSld>
     <p:spTree>
@@ -13527,7 +13759,7 @@
 </p:sld>
 </file>
 
-<file path=ppt/slides/slide22.xml><?xml version="1.0" encoding="utf-8"?>
+<file path=ppt/slides/slide24.xml><?xml version="1.0" encoding="utf-8"?>
 <p:sld xmlns:a="http://schemas.openxmlformats.org/drawingml/2006/main" xmlns:r="http://schemas.openxmlformats.org/officeDocument/2006/relationships" xmlns:p="http://schemas.openxmlformats.org/presentationml/2006/main">
   <p:cSld>
     <p:spTree>
@@ -13828,7 +14060,7 @@
 </p:sld>
 </file>
 
-<file path=ppt/slides/slide23.xml><?xml version="1.0" encoding="utf-8"?>
+<file path=ppt/slides/slide25.xml><?xml version="1.0" encoding="utf-8"?>
 <p:sld xmlns:a="http://schemas.openxmlformats.org/drawingml/2006/main" xmlns:r="http://schemas.openxmlformats.org/officeDocument/2006/relationships" xmlns:p="http://schemas.openxmlformats.org/presentationml/2006/main">
   <p:cSld>
     <p:spTree>
@@ -14293,7 +14525,7 @@
 </p:sld>
 </file>
 
-<file path=ppt/slides/slide24.xml><?xml version="1.0" encoding="utf-8"?>
+<file path=ppt/slides/slide26.xml><?xml version="1.0" encoding="utf-8"?>
 <p:sld xmlns:a="http://schemas.openxmlformats.org/drawingml/2006/main" xmlns:r="http://schemas.openxmlformats.org/officeDocument/2006/relationships" xmlns:p="http://schemas.openxmlformats.org/presentationml/2006/main">
   <p:cSld>
     <p:spTree>
@@ -14405,7 +14637,7 @@
 </p:sld>
 </file>
 
-<file path=ppt/slides/slide25.xml><?xml version="1.0" encoding="utf-8"?>
+<file path=ppt/slides/slide27.xml><?xml version="1.0" encoding="utf-8"?>
 <p:sld xmlns:a="http://schemas.openxmlformats.org/drawingml/2006/main" xmlns:r="http://schemas.openxmlformats.org/officeDocument/2006/relationships" xmlns:p="http://schemas.openxmlformats.org/presentationml/2006/main">
   <p:cSld>
     <p:spTree>
@@ -14720,7 +14952,7 @@
 </p:sld>
 </file>
 
-<file path=ppt/slides/slide26.xml><?xml version="1.0" encoding="utf-8"?>
+<file path=ppt/slides/slide28.xml><?xml version="1.0" encoding="utf-8"?>
 <p:sld xmlns:a="http://schemas.openxmlformats.org/drawingml/2006/main" xmlns:r="http://schemas.openxmlformats.org/officeDocument/2006/relationships" xmlns:p="http://schemas.openxmlformats.org/presentationml/2006/main">
   <p:cSld>
     <p:spTree>
@@ -15035,7 +15267,7 @@
 </p:sld>
 </file>
 
-<file path=ppt/slides/slide27.xml><?xml version="1.0" encoding="utf-8"?>
+<file path=ppt/slides/slide29.xml><?xml version="1.0" encoding="utf-8"?>
 <p:sld xmlns:a="http://schemas.openxmlformats.org/drawingml/2006/main" xmlns:r="http://schemas.openxmlformats.org/officeDocument/2006/relationships" xmlns:p="http://schemas.openxmlformats.org/presentationml/2006/main">
   <p:cSld>
     <p:spTree>
@@ -15344,7 +15576,174 @@
 </p:sld>
 </file>
 
-<file path=ppt/slides/slide28.xml><?xml version="1.0" encoding="utf-8"?>
+<file path=ppt/slides/slide3.xml><?xml version="1.0" encoding="utf-8"?>
+<p:sld xmlns:a="http://schemas.openxmlformats.org/drawingml/2006/main" xmlns:r="http://schemas.openxmlformats.org/officeDocument/2006/relationships" xmlns:p="http://schemas.openxmlformats.org/presentationml/2006/main">
+  <p:cSld>
+    <p:spTree>
+      <p:nvGrpSpPr>
+        <p:cNvPr id="1" name=""/>
+        <p:cNvGrpSpPr/>
+        <p:nvPr/>
+      </p:nvGrpSpPr>
+      <p:grpSpPr>
+        <a:xfrm>
+          <a:off x="0" y="0"/>
+          <a:ext cx="0" cy="0"/>
+          <a:chOff x="0" y="0"/>
+          <a:chExt cx="0" cy="0"/>
+        </a:xfrm>
+      </p:grpSpPr>
+      <p:sp>
+        <p:nvSpPr>
+          <p:cNvPr id="65" name="Google Shape;65;p14"/>
+          <p:cNvSpPr/>
+          <p:nvPr/>
+        </p:nvSpPr>
+        <p:spPr>
+          <a:xfrm rot="10800000" flipH="1">
+            <a:off x="-9816" y="2428866"/>
+            <a:ext cx="9163638" cy="2714634"/>
+          </a:xfrm>
+          <a:prstGeom prst="flowChartDocument">
+            <a:avLst/>
+          </a:prstGeom>
+          <a:solidFill>
+            <a:srgbClr val="DEF5FF"/>
+          </a:solidFill>
+          <a:ln>
+            <a:noFill/>
+          </a:ln>
+        </p:spPr>
+        <p:txBody>
+          <a:bodyPr spcFirstLastPara="1" wrap="square" lIns="91425" tIns="91425" rIns="91425" bIns="91425" anchor="ctr" anchorCtr="0">
+            <a:noAutofit/>
+          </a:bodyPr>
+          <a:lstStyle/>
+          <a:p>
+            <a:pPr marL="0" lvl="0" indent="0" algn="ctr" rtl="0">
+              <a:spcBef>
+                <a:spcPts val="0"/>
+              </a:spcBef>
+              <a:spcAft>
+                <a:spcPts val="0"/>
+              </a:spcAft>
+              <a:buNone/>
+            </a:pPr>
+            <a:endParaRPr/>
+          </a:p>
+        </p:txBody>
+      </p:sp>
+      <p:pic>
+        <p:nvPicPr>
+          <p:cNvPr id="66" name="Google Shape;66;p14" title="Wave.png"/>
+          <p:cNvPicPr preferRelativeResize="0"/>
+          <p:nvPr/>
+        </p:nvPicPr>
+        <p:blipFill rotWithShape="1">
+          <a:blip r:embed="rId3">
+            <a:alphaModFix/>
+          </a:blip>
+          <a:srcRect l="1896" r="1886" b="28947"/>
+          <a:stretch/>
+        </p:blipFill>
+        <p:spPr>
+          <a:xfrm>
+            <a:off x="2145" y="3455650"/>
+            <a:ext cx="9151677" cy="1687850"/>
+          </a:xfrm>
+          <a:prstGeom prst="rect">
+            <a:avLst/>
+          </a:prstGeom>
+          <a:noFill/>
+          <a:ln>
+            <a:noFill/>
+          </a:ln>
+        </p:spPr>
+      </p:pic>
+      <p:pic>
+        <p:nvPicPr>
+          <p:cNvPr id="70" name="Google Shape;70;p14" title="Tentacles.png"/>
+          <p:cNvPicPr preferRelativeResize="0"/>
+          <p:nvPr/>
+        </p:nvPicPr>
+        <p:blipFill>
+          <a:blip r:embed="rId4">
+            <a:alphaModFix/>
+          </a:blip>
+          <a:stretch>
+            <a:fillRect/>
+          </a:stretch>
+        </p:blipFill>
+        <p:spPr>
+          <a:xfrm>
+            <a:off x="5864377" y="3364666"/>
+            <a:ext cx="3406625" cy="1787075"/>
+          </a:xfrm>
+          <a:prstGeom prst="rect">
+            <a:avLst/>
+          </a:prstGeom>
+          <a:noFill/>
+          <a:ln>
+            <a:noFill/>
+          </a:ln>
+        </p:spPr>
+      </p:pic>
+      <p:sp>
+        <p:nvSpPr>
+          <p:cNvPr id="71" name="Google Shape;71;p14"/>
+          <p:cNvSpPr txBox="1">
+            <a:spLocks noGrp="1"/>
+          </p:cNvSpPr>
+          <p:nvPr>
+            <p:ph type="ctrTitle"/>
+          </p:nvPr>
+        </p:nvSpPr>
+        <p:spPr>
+          <a:xfrm>
+            <a:off x="311700" y="744575"/>
+            <a:ext cx="8520600" cy="1446300"/>
+          </a:xfrm>
+          <a:prstGeom prst="rect">
+            <a:avLst/>
+          </a:prstGeom>
+        </p:spPr>
+        <p:txBody>
+          <a:bodyPr spcFirstLastPara="1" wrap="square" lIns="91425" tIns="91425" rIns="91425" bIns="91425" anchor="b" anchorCtr="0">
+            <a:normAutofit/>
+          </a:bodyPr>
+          <a:lstStyle/>
+          <a:p>
+            <a:pPr marL="0" lvl="0" indent="0" algn="l" rtl="0">
+              <a:spcBef>
+                <a:spcPts val="0"/>
+              </a:spcBef>
+              <a:spcAft>
+                <a:spcPts val="0"/>
+              </a:spcAft>
+              <a:buNone/>
+            </a:pPr>
+            <a:r>
+              <a:rPr lang="en-GB" sz="4000" b="1" dirty="0">
+                <a:solidFill>
+                  <a:srgbClr val="10265D"/>
+                </a:solidFill>
+                <a:latin typeface="Etna"/>
+              </a:rPr>
+              <a:t>One day someone asked me if I wanted to cycle 205 miles in one day…</a:t>
+            </a:r>
+            <a:endParaRPr dirty="0"/>
+          </a:p>
+        </p:txBody>
+      </p:sp>
+    </p:spTree>
+  </p:cSld>
+  <p:clrMapOvr>
+    <a:masterClrMapping/>
+  </p:clrMapOvr>
+</p:sld>
+</file>
+
+<file path=ppt/slides/slide30.xml><?xml version="1.0" encoding="utf-8"?>
 <p:sld xmlns:a="http://schemas.openxmlformats.org/drawingml/2006/main" xmlns:r="http://schemas.openxmlformats.org/officeDocument/2006/relationships" xmlns:p="http://schemas.openxmlformats.org/presentationml/2006/main">
   <p:cSld>
     <p:spTree>
@@ -15753,173 +16152,6 @@
               </a:rPr>
               <a:t>Watch this space for the Chase the Sun post-mortem.</a:t>
             </a:r>
-          </a:p>
-        </p:txBody>
-      </p:sp>
-    </p:spTree>
-  </p:cSld>
-  <p:clrMapOvr>
-    <a:masterClrMapping/>
-  </p:clrMapOvr>
-</p:sld>
-</file>
-
-<file path=ppt/slides/slide3.xml><?xml version="1.0" encoding="utf-8"?>
-<p:sld xmlns:a="http://schemas.openxmlformats.org/drawingml/2006/main" xmlns:r="http://schemas.openxmlformats.org/officeDocument/2006/relationships" xmlns:p="http://schemas.openxmlformats.org/presentationml/2006/main">
-  <p:cSld>
-    <p:spTree>
-      <p:nvGrpSpPr>
-        <p:cNvPr id="1" name=""/>
-        <p:cNvGrpSpPr/>
-        <p:nvPr/>
-      </p:nvGrpSpPr>
-      <p:grpSpPr>
-        <a:xfrm>
-          <a:off x="0" y="0"/>
-          <a:ext cx="0" cy="0"/>
-          <a:chOff x="0" y="0"/>
-          <a:chExt cx="0" cy="0"/>
-        </a:xfrm>
-      </p:grpSpPr>
-      <p:sp>
-        <p:nvSpPr>
-          <p:cNvPr id="65" name="Google Shape;65;p14"/>
-          <p:cNvSpPr/>
-          <p:nvPr/>
-        </p:nvSpPr>
-        <p:spPr>
-          <a:xfrm rot="10800000" flipH="1">
-            <a:off x="-9816" y="2428866"/>
-            <a:ext cx="9163638" cy="2714634"/>
-          </a:xfrm>
-          <a:prstGeom prst="flowChartDocument">
-            <a:avLst/>
-          </a:prstGeom>
-          <a:solidFill>
-            <a:srgbClr val="DEF5FF"/>
-          </a:solidFill>
-          <a:ln>
-            <a:noFill/>
-          </a:ln>
-        </p:spPr>
-        <p:txBody>
-          <a:bodyPr spcFirstLastPara="1" wrap="square" lIns="91425" tIns="91425" rIns="91425" bIns="91425" anchor="ctr" anchorCtr="0">
-            <a:noAutofit/>
-          </a:bodyPr>
-          <a:lstStyle/>
-          <a:p>
-            <a:pPr marL="0" lvl="0" indent="0" algn="ctr" rtl="0">
-              <a:spcBef>
-                <a:spcPts val="0"/>
-              </a:spcBef>
-              <a:spcAft>
-                <a:spcPts val="0"/>
-              </a:spcAft>
-              <a:buNone/>
-            </a:pPr>
-            <a:endParaRPr/>
-          </a:p>
-        </p:txBody>
-      </p:sp>
-      <p:pic>
-        <p:nvPicPr>
-          <p:cNvPr id="66" name="Google Shape;66;p14" title="Wave.png"/>
-          <p:cNvPicPr preferRelativeResize="0"/>
-          <p:nvPr/>
-        </p:nvPicPr>
-        <p:blipFill rotWithShape="1">
-          <a:blip r:embed="rId3">
-            <a:alphaModFix/>
-          </a:blip>
-          <a:srcRect l="1896" r="1886" b="28947"/>
-          <a:stretch/>
-        </p:blipFill>
-        <p:spPr>
-          <a:xfrm>
-            <a:off x="2145" y="3455650"/>
-            <a:ext cx="9151677" cy="1687850"/>
-          </a:xfrm>
-          <a:prstGeom prst="rect">
-            <a:avLst/>
-          </a:prstGeom>
-          <a:noFill/>
-          <a:ln>
-            <a:noFill/>
-          </a:ln>
-        </p:spPr>
-      </p:pic>
-      <p:pic>
-        <p:nvPicPr>
-          <p:cNvPr id="70" name="Google Shape;70;p14" title="Tentacles.png"/>
-          <p:cNvPicPr preferRelativeResize="0"/>
-          <p:nvPr/>
-        </p:nvPicPr>
-        <p:blipFill>
-          <a:blip r:embed="rId4">
-            <a:alphaModFix/>
-          </a:blip>
-          <a:stretch>
-            <a:fillRect/>
-          </a:stretch>
-        </p:blipFill>
-        <p:spPr>
-          <a:xfrm>
-            <a:off x="5864377" y="3364666"/>
-            <a:ext cx="3406625" cy="1787075"/>
-          </a:xfrm>
-          <a:prstGeom prst="rect">
-            <a:avLst/>
-          </a:prstGeom>
-          <a:noFill/>
-          <a:ln>
-            <a:noFill/>
-          </a:ln>
-        </p:spPr>
-      </p:pic>
-      <p:sp>
-        <p:nvSpPr>
-          <p:cNvPr id="71" name="Google Shape;71;p14"/>
-          <p:cNvSpPr txBox="1">
-            <a:spLocks noGrp="1"/>
-          </p:cNvSpPr>
-          <p:nvPr>
-            <p:ph type="ctrTitle"/>
-          </p:nvPr>
-        </p:nvSpPr>
-        <p:spPr>
-          <a:xfrm>
-            <a:off x="311700" y="744575"/>
-            <a:ext cx="8520600" cy="1446300"/>
-          </a:xfrm>
-          <a:prstGeom prst="rect">
-            <a:avLst/>
-          </a:prstGeom>
-        </p:spPr>
-        <p:txBody>
-          <a:bodyPr spcFirstLastPara="1" wrap="square" lIns="91425" tIns="91425" rIns="91425" bIns="91425" anchor="b" anchorCtr="0">
-            <a:normAutofit/>
-          </a:bodyPr>
-          <a:lstStyle/>
-          <a:p>
-            <a:pPr marL="0" lvl="0" indent="0" algn="l" rtl="0">
-              <a:spcBef>
-                <a:spcPts val="0"/>
-              </a:spcBef>
-              <a:spcAft>
-                <a:spcPts val="0"/>
-              </a:spcAft>
-              <a:buNone/>
-            </a:pPr>
-            <a:r>
-              <a:rPr lang="en-GB" sz="4000" b="1" dirty="0">
-                <a:solidFill>
-                  <a:srgbClr val="10265D"/>
-                </a:solidFill>
-                <a:latin typeface="Etna"/>
-              </a:rPr>
-              <a:t>One day someone asked me if I wanted to cycle 205 miles in one day…</a:t>
-            </a:r>
-            <a:endParaRPr dirty="0"/>
           </a:p>
         </p:txBody>
       </p:sp>

</xml_diff>